<commit_message>
v2.27 (John's word, 8 October): day boxes under the homework practice wherever it is daily — Sessions 6, 8, 12, 14 (sheets still one page; S6 tightened, title rule kept); each deck's Four Parts slide re-cut from the new sheet
Co-Authored-By: Claude Opus 5.5 <noreply@anthropic.com>
</commit_message>
<xml_diff>
--- a/_implementation-notes/evening-series/FotH Evening Session 12 Slides DRAFT v1.pptx
+++ b/_implementation-notes/evening-series/FotH Evening Session 12 Slides DRAFT v1.pptx
@@ -5519,15 +5519,15 @@
           <p:nvPr/>
         </p:nvPicPr>
         <p:blipFill>
-          <a:blip r:embed="rId2"/>
+          <a:blip r:embed="rId4"/>
           <a:stretch>
             <a:fillRect/>
           </a:stretch>
         </p:blipFill>
         <p:spPr>
           <a:xfrm>
-            <a:off x="2066004" y="1463040"/>
-            <a:ext cx="8059687" cy="4709160"/>
+            <a:off x="2697485" y="1463040"/>
+            <a:ext cx="6796725" cy="4709160"/>
           </a:xfrm>
           <a:prstGeom prst="rect">
             <a:avLst/>

</xml_diff>

<commit_message>
v2.37 (John's word, 13 October): the school calendar stripped from Evenings 9-14 (and stray lines in 2, 4, 15, 16): no Christmas, spring break, January or Wednesdays; the two built-in returns kept with a note that the break may be just the two weeks; Evening 13's Christmas precedent removed
Co-Authored-By: Claude Opus 5.5 <noreply@anthropic.com>
</commit_message>
<xml_diff>
--- a/_implementation-notes/evening-series/FotH Evening Session 12 Slides DRAFT v1.pptx
+++ b/_implementation-notes/evening-series/FotH Evening Session 12 Slides DRAFT v1.pptx
@@ -1049,7 +1049,7 @@
           </a:p>
           <a:p>
             <a:r>
-              <a:t>BEATS: 1. First evenings back after Christmas — nothing new is taught today; the whole evening rebuilds what the break interrupted. 2. Three movements: 'What held?' in pairs; the Walk Home (the Path Home Card enacted); re-anchoring the year's map. 3. Deliberately adult-carried today — the container protocol itself is the teaching.</a:t>
+              <a:t>BEATS: 1. First evening back after the break — nothing new is taught today; the whole evening rebuilds what the break interrupted. If no holiday break falls before this evening, the break is simply the two weeks since we last met; the evening form runs this test at every return. 2. Three movements: 'What held?' in pairs; the Walk Home (the Path Home Card enacted); re-anchoring the year's map. 3. Deliberately adult-carried today — the container protocol itself is the teaching.</a:t>
             </a:r>
           </a:p>
           <a:p>
@@ -7344,7 +7344,7 @@
                 </a:solidFill>
                 <a:latin typeface="Calibri"/>
               </a:rPr>
-              <a:t>Two weeks without Wednesdays — containers don’t keep. They are rebuilt every time, by the same small faithful steps</a:t>
+              <a:t>Time apart — containers don’t keep. They are rebuilt every time, by the same small faithful steps</a:t>
             </a:r>
           </a:p>
           <a:p>

</xml_diff>